<commit_message>
fix(y9-l8): drop CD-player framing, audio plays via projector
L3/L6 materials lists and slide labels said "CD player" / "CD Track"
as if separate equipment was needed. Classroom only has a projector
and whiteboard — audio plays through the projector's own speakers, so
reworded to "Track N" throughout the lesson plans, slide decks, and
the two affected PPTX exports (patched in place).

Co-Authored-By: Claude Sonnet 5 <noreply@anthropic.com>
</commit_message>
<xml_diff>
--- a/index/designs/y9-l8/l3-rooms-floors/l3-rooms-floors.pptx
+++ b/index/designs/y9-l8/l3-rooms-floors/l3-rooms-floors.pptx
@@ -2688,7 +2688,7 @@
                 <a:ea typeface="Noto Sans SC" pitchFamily="34" charset="-122"/>
                 <a:cs typeface="Noto Sans SC" pitchFamily="34" charset="-120"/>
               </a:rPr>
-              <a:t>CD Track 31</a:t>
+              <a:t>Track 31</a:t>
             </a:r>
             <a:endParaRPr lang="en-US" sz="1100" dirty="0"/>
           </a:p>
@@ -3105,7 +3105,7 @@
                 <a:ea typeface="Noto Sans SC" pitchFamily="34" charset="-122"/>
                 <a:cs typeface="Noto Sans SC" pitchFamily="34" charset="-120"/>
               </a:rPr>
-              <a:t>▶ CD Track 31</a:t>
+              <a:t>▶ Track 31</a:t>
             </a:r>
             <a:endParaRPr lang="en-US" sz="750" dirty="0"/>
           </a:p>
@@ -3218,7 +3218,7 @@
                 <a:ea typeface="Noto Sans SC" pitchFamily="34" charset="-122"/>
                 <a:cs typeface="Noto Sans SC" pitchFamily="34" charset="-120"/>
               </a:rPr>
-              <a:t>播放 CD Track 31，拼音可见，学生默默跟听。</a:t>
+              <a:t>播放 Track 31，拼音可见，学生默默跟听。</a:t>
             </a:r>
             <a:endParaRPr lang="en-US" sz="900" dirty="0"/>
           </a:p>
@@ -22304,7 +22304,7 @@
                 <a:ea typeface="Noto Sans SC" pitchFamily="34" charset="-122"/>
                 <a:cs typeface="Noto Sans SC" pitchFamily="34" charset="-120"/>
               </a:rPr>
-              <a:t>▶ CD Track 31</a:t>
+              <a:t>▶ Track 31</a:t>
             </a:r>
             <a:endParaRPr lang="en-US" sz="900" dirty="0"/>
           </a:p>
@@ -23711,7 +23711,7 @@
                 <a:ea typeface="Noto Sans SC" pitchFamily="34" charset="-122"/>
                 <a:cs typeface="Noto Sans SC" pitchFamily="34" charset="-120"/>
               </a:rPr>
-              <a:t>教师朗读一遍课文（角色分明），全班跟看拼音；播放 CD Track 31。今天可用英文作答，欢迎流利的学生用中文复述。</a:t>
+              <a:t>教师朗读一遍课文（角色分明），全班跟看拼音；播放 Track 31。今天可用英文作答，欢迎流利的学生用中文复述。</a:t>
             </a:r>
             <a:endParaRPr lang="en-US" sz="800" dirty="0"/>
           </a:p>

</xml_diff>